<commit_message>
Add interactive LSTM explainer to Sequence Analyzer dashboard
- LstmFlow panel: visualizes the input window -> LSTM memory cell (64 units) -> fraud score -> action
- PipelineExplainer: 6-step clickable walkthrough (data injection, feature engineering,
  flat-table-to-sequences conversion, why LSTM/RNN, score-to-action, into the dashboard),
  grounded in the selected customer's real data
- Refresh sequence analyzer screenshot

Co-Authored-By: Claude Opus 4.8 <noreply@anthropic.com>
</commit_message>
<xml_diff>
--- a/FraudShield_AI_LSTM_DL_Project.pptx
+++ b/FraudShield_AI_LSTM_DL_Project.pptx
@@ -3267,7 +3267,7 @@
       </p:sp>
       <p:sp>
         <p:nvSpPr>
-          <p:cNvPr id="4" name="Shape 2"/>
+          <p:cNvPr id="5" name="Text 3"/>
           <p:cNvSpPr/>
           <p:nvPr/>
         </p:nvSpPr>
@@ -3276,40 +3276,6 @@
             <a:off x="8945575" y="457200"/>
             <a:ext cx="2697480" cy="457200"/>
           </a:xfrm>
-          <a:prstGeom prst="roundRect">
-            <a:avLst>
-              <a:gd name="adj" fmla="val 50000"/>
-            </a:avLst>
-          </a:prstGeom>
-          <a:solidFill>
-            <a:srgbClr val="1B2540"/>
-          </a:solidFill>
-          <a:ln w="12700">
-            <a:solidFill>
-              <a:srgbClr val="2A3550"/>
-            </a:solidFill>
-            <a:prstDash val="solid"/>
-          </a:ln>
-        </p:spPr>
-        <p:txBody>
-          <a:bodyPr/>
-          <a:lstStyle/>
-          <a:p>
-            <a:endParaRPr lang="en-US"/>
-          </a:p>
-        </p:txBody>
-      </p:sp>
-      <p:sp>
-        <p:nvSpPr>
-          <p:cNvPr id="5" name="Text 3"/>
-          <p:cNvSpPr/>
-          <p:nvPr/>
-        </p:nvSpPr>
-        <p:spPr>
-          <a:xfrm>
-            <a:off x="8945575" y="457200"/>
-            <a:ext cx="2697480" cy="457200"/>
-          </a:xfrm>
           <a:prstGeom prst="rect">
             <a:avLst/>
           </a:prstGeom>
@@ -3323,28 +3289,6 @@
             <a:pPr marL="0" indent="0" algn="ctr">
               <a:buNone/>
             </a:pPr>
-            <a:r>
-              <a:rPr lang="en-US" sz="900" b="1" kern="0" spc="100" dirty="0">
-                <a:solidFill>
-                  <a:srgbClr val="8A98B5"/>
-                </a:solidFill>
-                <a:latin typeface="Calibri" pitchFamily="34" charset="0"/>
-                <a:ea typeface="Calibri" pitchFamily="34" charset="-122"/>
-                <a:cs typeface="Calibri" pitchFamily="34" charset="-120"/>
-              </a:rPr>
-              <a:t>PRESENTER   </a:t>
-            </a:r>
-            <a:r>
-              <a:rPr lang="en-US" sz="1100" b="1" dirty="0">
-                <a:solidFill>
-                  <a:srgbClr val="FFFFFF"/>
-                </a:solidFill>
-                <a:latin typeface="Calibri" pitchFamily="34" charset="0"/>
-                <a:ea typeface="Calibri" pitchFamily="34" charset="-122"/>
-                <a:cs typeface="Calibri" pitchFamily="34" charset="-120"/>
-              </a:rPr>
-              <a:t>Yash Petkar</a:t>
-            </a:r>
             <a:endParaRPr lang="en-US" sz="900" dirty="0"/>
           </a:p>
         </p:txBody>
@@ -5235,7 +5179,7 @@
       </p:sp>
       <p:sp>
         <p:nvSpPr>
-          <p:cNvPr id="4" name="Shape 2"/>
+          <p:cNvPr id="5" name="Text 3"/>
           <p:cNvSpPr/>
           <p:nvPr/>
         </p:nvSpPr>
@@ -5244,40 +5188,6 @@
             <a:off x="8945575" y="457200"/>
             <a:ext cx="2697480" cy="457200"/>
           </a:xfrm>
-          <a:prstGeom prst="roundRect">
-            <a:avLst>
-              <a:gd name="adj" fmla="val 50000"/>
-            </a:avLst>
-          </a:prstGeom>
-          <a:solidFill>
-            <a:srgbClr val="1B2540"/>
-          </a:solidFill>
-          <a:ln w="12700">
-            <a:solidFill>
-              <a:srgbClr val="2A3550"/>
-            </a:solidFill>
-            <a:prstDash val="solid"/>
-          </a:ln>
-        </p:spPr>
-        <p:txBody>
-          <a:bodyPr/>
-          <a:lstStyle/>
-          <a:p>
-            <a:endParaRPr lang="en-US"/>
-          </a:p>
-        </p:txBody>
-      </p:sp>
-      <p:sp>
-        <p:nvSpPr>
-          <p:cNvPr id="5" name="Text 3"/>
-          <p:cNvSpPr/>
-          <p:nvPr/>
-        </p:nvSpPr>
-        <p:spPr>
-          <a:xfrm>
-            <a:off x="8945575" y="457200"/>
-            <a:ext cx="2697480" cy="457200"/>
-          </a:xfrm>
           <a:prstGeom prst="rect">
             <a:avLst/>
           </a:prstGeom>
@@ -5291,28 +5201,6 @@
             <a:pPr marL="0" indent="0" algn="ctr">
               <a:buNone/>
             </a:pPr>
-            <a:r>
-              <a:rPr lang="en-US" sz="900" b="1" kern="0" spc="100" dirty="0">
-                <a:solidFill>
-                  <a:srgbClr val="8A98B5"/>
-                </a:solidFill>
-                <a:latin typeface="Calibri" pitchFamily="34" charset="0"/>
-                <a:ea typeface="Calibri" pitchFamily="34" charset="-122"/>
-                <a:cs typeface="Calibri" pitchFamily="34" charset="-120"/>
-              </a:rPr>
-              <a:t>PRESENTER   </a:t>
-            </a:r>
-            <a:r>
-              <a:rPr lang="en-US" sz="1100" b="1" dirty="0">
-                <a:solidFill>
-                  <a:srgbClr val="FFFFFF"/>
-                </a:solidFill>
-                <a:latin typeface="Calibri" pitchFamily="34" charset="0"/>
-                <a:ea typeface="Calibri" pitchFamily="34" charset="-122"/>
-                <a:cs typeface="Calibri" pitchFamily="34" charset="-120"/>
-              </a:rPr>
-              <a:t>Krishna Mathur</a:t>
-            </a:r>
             <a:endParaRPr lang="en-US" sz="900" dirty="0"/>
           </a:p>
         </p:txBody>
@@ -6455,7 +6343,7 @@
       </p:sp>
       <p:sp>
         <p:nvSpPr>
-          <p:cNvPr id="4" name="Shape 2"/>
+          <p:cNvPr id="5" name="Text 3"/>
           <p:cNvSpPr/>
           <p:nvPr/>
         </p:nvSpPr>
@@ -6464,40 +6352,6 @@
             <a:off x="8945575" y="457200"/>
             <a:ext cx="2697480" cy="457200"/>
           </a:xfrm>
-          <a:prstGeom prst="roundRect">
-            <a:avLst>
-              <a:gd name="adj" fmla="val 50000"/>
-            </a:avLst>
-          </a:prstGeom>
-          <a:solidFill>
-            <a:srgbClr val="1B2540"/>
-          </a:solidFill>
-          <a:ln w="12700">
-            <a:solidFill>
-              <a:srgbClr val="2A3550"/>
-            </a:solidFill>
-            <a:prstDash val="solid"/>
-          </a:ln>
-        </p:spPr>
-        <p:txBody>
-          <a:bodyPr/>
-          <a:lstStyle/>
-          <a:p>
-            <a:endParaRPr lang="en-US"/>
-          </a:p>
-        </p:txBody>
-      </p:sp>
-      <p:sp>
-        <p:nvSpPr>
-          <p:cNvPr id="5" name="Text 3"/>
-          <p:cNvSpPr/>
-          <p:nvPr/>
-        </p:nvSpPr>
-        <p:spPr>
-          <a:xfrm>
-            <a:off x="8945575" y="457200"/>
-            <a:ext cx="2697480" cy="457200"/>
-          </a:xfrm>
           <a:prstGeom prst="rect">
             <a:avLst/>
           </a:prstGeom>
@@ -6511,28 +6365,6 @@
             <a:pPr marL="0" indent="0" algn="ctr">
               <a:buNone/>
             </a:pPr>
-            <a:r>
-              <a:rPr lang="en-US" sz="900" b="1" kern="0" spc="100" dirty="0">
-                <a:solidFill>
-                  <a:srgbClr val="8A98B5"/>
-                </a:solidFill>
-                <a:latin typeface="Calibri" pitchFamily="34" charset="0"/>
-                <a:ea typeface="Calibri" pitchFamily="34" charset="-122"/>
-                <a:cs typeface="Calibri" pitchFamily="34" charset="-120"/>
-              </a:rPr>
-              <a:t>PRESENTER   </a:t>
-            </a:r>
-            <a:r>
-              <a:rPr lang="en-US" sz="1100" b="1" dirty="0">
-                <a:solidFill>
-                  <a:srgbClr val="FFFFFF"/>
-                </a:solidFill>
-                <a:latin typeface="Calibri" pitchFamily="34" charset="0"/>
-                <a:ea typeface="Calibri" pitchFamily="34" charset="-122"/>
-                <a:cs typeface="Calibri" pitchFamily="34" charset="-120"/>
-              </a:rPr>
-              <a:t>Krish Kumar</a:t>
-            </a:r>
             <a:endParaRPr lang="en-US" sz="900" dirty="0"/>
           </a:p>
         </p:txBody>
@@ -7891,7 +7723,7 @@
       </p:sp>
       <p:sp>
         <p:nvSpPr>
-          <p:cNvPr id="4" name="Shape 2"/>
+          <p:cNvPr id="5" name="Text 3"/>
           <p:cNvSpPr/>
           <p:nvPr/>
         </p:nvSpPr>
@@ -7900,40 +7732,6 @@
             <a:off x="8945575" y="457200"/>
             <a:ext cx="2697480" cy="457200"/>
           </a:xfrm>
-          <a:prstGeom prst="roundRect">
-            <a:avLst>
-              <a:gd name="adj" fmla="val 50000"/>
-            </a:avLst>
-          </a:prstGeom>
-          <a:solidFill>
-            <a:srgbClr val="1B2540"/>
-          </a:solidFill>
-          <a:ln w="12700">
-            <a:solidFill>
-              <a:srgbClr val="2A3550"/>
-            </a:solidFill>
-            <a:prstDash val="solid"/>
-          </a:ln>
-        </p:spPr>
-        <p:txBody>
-          <a:bodyPr/>
-          <a:lstStyle/>
-          <a:p>
-            <a:endParaRPr lang="en-US"/>
-          </a:p>
-        </p:txBody>
-      </p:sp>
-      <p:sp>
-        <p:nvSpPr>
-          <p:cNvPr id="5" name="Text 3"/>
-          <p:cNvSpPr/>
-          <p:nvPr/>
-        </p:nvSpPr>
-        <p:spPr>
-          <a:xfrm>
-            <a:off x="8945575" y="457200"/>
-            <a:ext cx="2697480" cy="457200"/>
-          </a:xfrm>
           <a:prstGeom prst="rect">
             <a:avLst/>
           </a:prstGeom>
@@ -7947,28 +7745,6 @@
             <a:pPr marL="0" indent="0" algn="ctr">
               <a:buNone/>
             </a:pPr>
-            <a:r>
-              <a:rPr lang="en-US" sz="900" b="1" kern="0" spc="100" dirty="0">
-                <a:solidFill>
-                  <a:srgbClr val="8A98B5"/>
-                </a:solidFill>
-                <a:latin typeface="Calibri" pitchFamily="34" charset="0"/>
-                <a:ea typeface="Calibri" pitchFamily="34" charset="-122"/>
-                <a:cs typeface="Calibri" pitchFamily="34" charset="-120"/>
-              </a:rPr>
-              <a:t>PRESENTER   </a:t>
-            </a:r>
-            <a:r>
-              <a:rPr lang="en-US" sz="1100" b="1" dirty="0">
-                <a:solidFill>
-                  <a:srgbClr val="FFFFFF"/>
-                </a:solidFill>
-                <a:latin typeface="Calibri" pitchFamily="34" charset="0"/>
-                <a:ea typeface="Calibri" pitchFamily="34" charset="-122"/>
-                <a:cs typeface="Calibri" pitchFamily="34" charset="-120"/>
-              </a:rPr>
-              <a:t>Krish Kumar</a:t>
-            </a:r>
             <a:endParaRPr lang="en-US" sz="900" dirty="0"/>
           </a:p>
         </p:txBody>
@@ -9877,7 +9653,7 @@
       </p:sp>
       <p:sp>
         <p:nvSpPr>
-          <p:cNvPr id="4" name="Shape 2"/>
+          <p:cNvPr id="5" name="Text 3"/>
           <p:cNvSpPr/>
           <p:nvPr/>
         </p:nvSpPr>
@@ -9886,40 +9662,6 @@
             <a:off x="8945575" y="457200"/>
             <a:ext cx="2697480" cy="457200"/>
           </a:xfrm>
-          <a:prstGeom prst="roundRect">
-            <a:avLst>
-              <a:gd name="adj" fmla="val 50000"/>
-            </a:avLst>
-          </a:prstGeom>
-          <a:solidFill>
-            <a:srgbClr val="1B2540"/>
-          </a:solidFill>
-          <a:ln w="12700">
-            <a:solidFill>
-              <a:srgbClr val="2A3550"/>
-            </a:solidFill>
-            <a:prstDash val="solid"/>
-          </a:ln>
-        </p:spPr>
-        <p:txBody>
-          <a:bodyPr/>
-          <a:lstStyle/>
-          <a:p>
-            <a:endParaRPr lang="en-US"/>
-          </a:p>
-        </p:txBody>
-      </p:sp>
-      <p:sp>
-        <p:nvSpPr>
-          <p:cNvPr id="5" name="Text 3"/>
-          <p:cNvSpPr/>
-          <p:nvPr/>
-        </p:nvSpPr>
-        <p:spPr>
-          <a:xfrm>
-            <a:off x="8945575" y="457200"/>
-            <a:ext cx="2697480" cy="457200"/>
-          </a:xfrm>
           <a:prstGeom prst="rect">
             <a:avLst/>
           </a:prstGeom>
@@ -9933,28 +9675,6 @@
             <a:pPr marL="0" indent="0" algn="ctr">
               <a:buNone/>
             </a:pPr>
-            <a:r>
-              <a:rPr lang="en-US" sz="900" b="1" kern="0" spc="100" dirty="0">
-                <a:solidFill>
-                  <a:srgbClr val="8A98B5"/>
-                </a:solidFill>
-                <a:latin typeface="Calibri" pitchFamily="34" charset="0"/>
-                <a:ea typeface="Calibri" pitchFamily="34" charset="-122"/>
-                <a:cs typeface="Calibri" pitchFamily="34" charset="-120"/>
-              </a:rPr>
-              <a:t>PRESENTER   </a:t>
-            </a:r>
-            <a:r>
-              <a:rPr lang="en-US" sz="1100" b="1" dirty="0">
-                <a:solidFill>
-                  <a:srgbClr val="FFFFFF"/>
-                </a:solidFill>
-                <a:latin typeface="Calibri" pitchFamily="34" charset="0"/>
-                <a:ea typeface="Calibri" pitchFamily="34" charset="-122"/>
-                <a:cs typeface="Calibri" pitchFamily="34" charset="-120"/>
-              </a:rPr>
-              <a:t>Atharva Soundankar</a:t>
-            </a:r>
             <a:endParaRPr lang="en-US" sz="900" dirty="0"/>
           </a:p>
         </p:txBody>
@@ -11949,7 +11669,7 @@
       </p:sp>
       <p:sp>
         <p:nvSpPr>
-          <p:cNvPr id="7" name="Shape 4"/>
+          <p:cNvPr id="8" name="Text 5"/>
           <p:cNvSpPr/>
           <p:nvPr/>
         </p:nvSpPr>
@@ -11958,40 +11678,6 @@
             <a:off x="8945575" y="457200"/>
             <a:ext cx="2697480" cy="457200"/>
           </a:xfrm>
-          <a:prstGeom prst="roundRect">
-            <a:avLst>
-              <a:gd name="adj" fmla="val 50000"/>
-            </a:avLst>
-          </a:prstGeom>
-          <a:solidFill>
-            <a:srgbClr val="1B2540"/>
-          </a:solidFill>
-          <a:ln w="12700">
-            <a:solidFill>
-              <a:srgbClr val="2A3550"/>
-            </a:solidFill>
-            <a:prstDash val="solid"/>
-          </a:ln>
-        </p:spPr>
-        <p:txBody>
-          <a:bodyPr/>
-          <a:lstStyle/>
-          <a:p>
-            <a:endParaRPr lang="en-US"/>
-          </a:p>
-        </p:txBody>
-      </p:sp>
-      <p:sp>
-        <p:nvSpPr>
-          <p:cNvPr id="8" name="Text 5"/>
-          <p:cNvSpPr/>
-          <p:nvPr/>
-        </p:nvSpPr>
-        <p:spPr>
-          <a:xfrm>
-            <a:off x="8945575" y="457200"/>
-            <a:ext cx="2697480" cy="457200"/>
-          </a:xfrm>
           <a:prstGeom prst="rect">
             <a:avLst/>
           </a:prstGeom>
@@ -12005,28 +11691,6 @@
             <a:pPr marL="0" indent="0" algn="ctr">
               <a:buNone/>
             </a:pPr>
-            <a:r>
-              <a:rPr lang="en-US" sz="900" b="1" kern="0" spc="100" dirty="0">
-                <a:solidFill>
-                  <a:srgbClr val="8A98B5"/>
-                </a:solidFill>
-                <a:latin typeface="Calibri" pitchFamily="34" charset="0"/>
-                <a:ea typeface="Calibri" pitchFamily="34" charset="-122"/>
-                <a:cs typeface="Calibri" pitchFamily="34" charset="-120"/>
-              </a:rPr>
-              <a:t>PRESENTER   </a:t>
-            </a:r>
-            <a:r>
-              <a:rPr lang="en-US" sz="1100" b="1" dirty="0">
-                <a:solidFill>
-                  <a:srgbClr val="FFFFFF"/>
-                </a:solidFill>
-                <a:latin typeface="Calibri" pitchFamily="34" charset="0"/>
-                <a:ea typeface="Calibri" pitchFamily="34" charset="-122"/>
-                <a:cs typeface="Calibri" pitchFamily="34" charset="-120"/>
-              </a:rPr>
-              <a:t>Krishna Mathur</a:t>
-            </a:r>
             <a:endParaRPr lang="en-US" sz="900" dirty="0"/>
           </a:p>
         </p:txBody>
@@ -13116,7 +12780,7 @@
       </p:sp>
       <p:sp>
         <p:nvSpPr>
-          <p:cNvPr id="4" name="Shape 2"/>
+          <p:cNvPr id="5" name="Text 3"/>
           <p:cNvSpPr/>
           <p:nvPr/>
         </p:nvSpPr>
@@ -13125,40 +12789,6 @@
             <a:off x="8945575" y="457200"/>
             <a:ext cx="2697480" cy="457200"/>
           </a:xfrm>
-          <a:prstGeom prst="roundRect">
-            <a:avLst>
-              <a:gd name="adj" fmla="val 50000"/>
-            </a:avLst>
-          </a:prstGeom>
-          <a:solidFill>
-            <a:srgbClr val="1B2540"/>
-          </a:solidFill>
-          <a:ln w="12700">
-            <a:solidFill>
-              <a:srgbClr val="2A3550"/>
-            </a:solidFill>
-            <a:prstDash val="solid"/>
-          </a:ln>
-        </p:spPr>
-        <p:txBody>
-          <a:bodyPr/>
-          <a:lstStyle/>
-          <a:p>
-            <a:endParaRPr lang="en-US"/>
-          </a:p>
-        </p:txBody>
-      </p:sp>
-      <p:sp>
-        <p:nvSpPr>
-          <p:cNvPr id="5" name="Text 3"/>
-          <p:cNvSpPr/>
-          <p:nvPr/>
-        </p:nvSpPr>
-        <p:spPr>
-          <a:xfrm>
-            <a:off x="8945575" y="457200"/>
-            <a:ext cx="2697480" cy="457200"/>
-          </a:xfrm>
           <a:prstGeom prst="rect">
             <a:avLst/>
           </a:prstGeom>
@@ -13172,28 +12802,6 @@
             <a:pPr marL="0" indent="0" algn="ctr">
               <a:buNone/>
             </a:pPr>
-            <a:r>
-              <a:rPr lang="en-US" sz="900" b="1" kern="0" spc="100" dirty="0">
-                <a:solidFill>
-                  <a:srgbClr val="8A98B5"/>
-                </a:solidFill>
-                <a:latin typeface="Calibri" pitchFamily="34" charset="0"/>
-                <a:ea typeface="Calibri" pitchFamily="34" charset="-122"/>
-                <a:cs typeface="Calibri" pitchFamily="34" charset="-120"/>
-              </a:rPr>
-              <a:t>PRESENTER   </a:t>
-            </a:r>
-            <a:r>
-              <a:rPr lang="en-US" sz="1100" b="1" dirty="0">
-                <a:solidFill>
-                  <a:srgbClr val="FFFFFF"/>
-                </a:solidFill>
-                <a:latin typeface="Calibri" pitchFamily="34" charset="0"/>
-                <a:ea typeface="Calibri" pitchFamily="34" charset="-122"/>
-                <a:cs typeface="Calibri" pitchFamily="34" charset="-120"/>
-              </a:rPr>
-              <a:t>Krishna Mathur</a:t>
-            </a:r>
             <a:endParaRPr lang="en-US" sz="900" dirty="0"/>
           </a:p>
         </p:txBody>
@@ -14479,7 +14087,7 @@
       </p:sp>
       <p:sp>
         <p:nvSpPr>
-          <p:cNvPr id="4" name="Shape 2"/>
+          <p:cNvPr id="5" name="Text 3"/>
           <p:cNvSpPr/>
           <p:nvPr/>
         </p:nvSpPr>
@@ -14488,40 +14096,6 @@
             <a:off x="8945575" y="457200"/>
             <a:ext cx="2697480" cy="457200"/>
           </a:xfrm>
-          <a:prstGeom prst="roundRect">
-            <a:avLst>
-              <a:gd name="adj" fmla="val 50000"/>
-            </a:avLst>
-          </a:prstGeom>
-          <a:solidFill>
-            <a:srgbClr val="1B2540"/>
-          </a:solidFill>
-          <a:ln w="12700">
-            <a:solidFill>
-              <a:srgbClr val="2A3550"/>
-            </a:solidFill>
-            <a:prstDash val="solid"/>
-          </a:ln>
-        </p:spPr>
-        <p:txBody>
-          <a:bodyPr/>
-          <a:lstStyle/>
-          <a:p>
-            <a:endParaRPr lang="en-US"/>
-          </a:p>
-        </p:txBody>
-      </p:sp>
-      <p:sp>
-        <p:nvSpPr>
-          <p:cNvPr id="5" name="Text 3"/>
-          <p:cNvSpPr/>
-          <p:nvPr/>
-        </p:nvSpPr>
-        <p:spPr>
-          <a:xfrm>
-            <a:off x="8945575" y="457200"/>
-            <a:ext cx="2697480" cy="457200"/>
-          </a:xfrm>
           <a:prstGeom prst="rect">
             <a:avLst/>
           </a:prstGeom>
@@ -14535,28 +14109,6 @@
             <a:pPr marL="0" indent="0" algn="ctr">
               <a:buNone/>
             </a:pPr>
-            <a:r>
-              <a:rPr lang="en-US" sz="900" b="1" kern="0" spc="100" dirty="0">
-                <a:solidFill>
-                  <a:srgbClr val="8A98B5"/>
-                </a:solidFill>
-                <a:latin typeface="Calibri" pitchFamily="34" charset="0"/>
-                <a:ea typeface="Calibri" pitchFamily="34" charset="-122"/>
-                <a:cs typeface="Calibri" pitchFamily="34" charset="-120"/>
-              </a:rPr>
-              <a:t>PRESENTER   </a:t>
-            </a:r>
-            <a:r>
-              <a:rPr lang="en-US" sz="1100" b="1" dirty="0">
-                <a:solidFill>
-                  <a:srgbClr val="FFFFFF"/>
-                </a:solidFill>
-                <a:latin typeface="Calibri" pitchFamily="34" charset="0"/>
-                <a:ea typeface="Calibri" pitchFamily="34" charset="-122"/>
-                <a:cs typeface="Calibri" pitchFamily="34" charset="-120"/>
-              </a:rPr>
-              <a:t>Krishna Mathur</a:t>
-            </a:r>
             <a:endParaRPr lang="en-US" sz="900" dirty="0"/>
           </a:p>
         </p:txBody>
@@ -15920,7 +15472,7 @@
       </p:sp>
       <p:sp>
         <p:nvSpPr>
-          <p:cNvPr id="4" name="Shape 2"/>
+          <p:cNvPr id="5" name="Text 3"/>
           <p:cNvSpPr/>
           <p:nvPr/>
         </p:nvSpPr>
@@ -15929,40 +15481,6 @@
             <a:off x="8945575" y="457200"/>
             <a:ext cx="2697480" cy="457200"/>
           </a:xfrm>
-          <a:prstGeom prst="roundRect">
-            <a:avLst>
-              <a:gd name="adj" fmla="val 50000"/>
-            </a:avLst>
-          </a:prstGeom>
-          <a:solidFill>
-            <a:srgbClr val="1B2540"/>
-          </a:solidFill>
-          <a:ln w="12700">
-            <a:solidFill>
-              <a:srgbClr val="2A3550"/>
-            </a:solidFill>
-            <a:prstDash val="solid"/>
-          </a:ln>
-        </p:spPr>
-        <p:txBody>
-          <a:bodyPr/>
-          <a:lstStyle/>
-          <a:p>
-            <a:endParaRPr lang="en-US"/>
-          </a:p>
-        </p:txBody>
-      </p:sp>
-      <p:sp>
-        <p:nvSpPr>
-          <p:cNvPr id="5" name="Text 3"/>
-          <p:cNvSpPr/>
-          <p:nvPr/>
-        </p:nvSpPr>
-        <p:spPr>
-          <a:xfrm>
-            <a:off x="8945575" y="457200"/>
-            <a:ext cx="2697480" cy="457200"/>
-          </a:xfrm>
           <a:prstGeom prst="rect">
             <a:avLst/>
           </a:prstGeom>
@@ -15976,28 +15494,6 @@
             <a:pPr marL="0" indent="0" algn="ctr">
               <a:buNone/>
             </a:pPr>
-            <a:r>
-              <a:rPr lang="en-US" sz="900" b="1" kern="0" spc="100" dirty="0">
-                <a:solidFill>
-                  <a:srgbClr val="8A98B5"/>
-                </a:solidFill>
-                <a:latin typeface="Calibri" pitchFamily="34" charset="0"/>
-                <a:ea typeface="Calibri" pitchFamily="34" charset="-122"/>
-                <a:cs typeface="Calibri" pitchFamily="34" charset="-120"/>
-              </a:rPr>
-              <a:t>PRESENTER   </a:t>
-            </a:r>
-            <a:r>
-              <a:rPr lang="en-US" sz="1100" b="1" dirty="0">
-                <a:solidFill>
-                  <a:srgbClr val="FFFFFF"/>
-                </a:solidFill>
-                <a:latin typeface="Calibri" pitchFamily="34" charset="0"/>
-                <a:ea typeface="Calibri" pitchFamily="34" charset="-122"/>
-                <a:cs typeface="Calibri" pitchFamily="34" charset="-120"/>
-              </a:rPr>
-              <a:t>Yash Petkar</a:t>
-            </a:r>
             <a:endParaRPr lang="en-US" sz="900" dirty="0"/>
           </a:p>
         </p:txBody>
@@ -16918,7 +16414,7 @@
       </p:sp>
       <p:sp>
         <p:nvSpPr>
-          <p:cNvPr id="4" name="Shape 2"/>
+          <p:cNvPr id="5" name="Text 3"/>
           <p:cNvSpPr/>
           <p:nvPr/>
         </p:nvSpPr>
@@ -16927,40 +16423,6 @@
             <a:off x="8945575" y="457200"/>
             <a:ext cx="2697480" cy="457200"/>
           </a:xfrm>
-          <a:prstGeom prst="roundRect">
-            <a:avLst>
-              <a:gd name="adj" fmla="val 50000"/>
-            </a:avLst>
-          </a:prstGeom>
-          <a:solidFill>
-            <a:srgbClr val="1B2540"/>
-          </a:solidFill>
-          <a:ln w="12700">
-            <a:solidFill>
-              <a:srgbClr val="2A3550"/>
-            </a:solidFill>
-            <a:prstDash val="solid"/>
-          </a:ln>
-        </p:spPr>
-        <p:txBody>
-          <a:bodyPr/>
-          <a:lstStyle/>
-          <a:p>
-            <a:endParaRPr lang="en-US"/>
-          </a:p>
-        </p:txBody>
-      </p:sp>
-      <p:sp>
-        <p:nvSpPr>
-          <p:cNvPr id="5" name="Text 3"/>
-          <p:cNvSpPr/>
-          <p:nvPr/>
-        </p:nvSpPr>
-        <p:spPr>
-          <a:xfrm>
-            <a:off x="8945575" y="457200"/>
-            <a:ext cx="2697480" cy="457200"/>
-          </a:xfrm>
           <a:prstGeom prst="rect">
             <a:avLst/>
           </a:prstGeom>
@@ -16974,28 +16436,6 @@
             <a:pPr marL="0" indent="0" algn="ctr">
               <a:buNone/>
             </a:pPr>
-            <a:r>
-              <a:rPr lang="en-US" sz="900" b="1" kern="0" spc="100" dirty="0">
-                <a:solidFill>
-                  <a:srgbClr val="8A98B5"/>
-                </a:solidFill>
-                <a:latin typeface="Calibri" pitchFamily="34" charset="0"/>
-                <a:ea typeface="Calibri" pitchFamily="34" charset="-122"/>
-                <a:cs typeface="Calibri" pitchFamily="34" charset="-120"/>
-              </a:rPr>
-              <a:t>PRESENTER   </a:t>
-            </a:r>
-            <a:r>
-              <a:rPr lang="en-US" sz="1100" b="1" dirty="0">
-                <a:solidFill>
-                  <a:srgbClr val="FFFFFF"/>
-                </a:solidFill>
-                <a:latin typeface="Calibri" pitchFamily="34" charset="0"/>
-                <a:ea typeface="Calibri" pitchFamily="34" charset="-122"/>
-                <a:cs typeface="Calibri" pitchFamily="34" charset="-120"/>
-              </a:rPr>
-              <a:t>Atharva Soundankar</a:t>
-            </a:r>
             <a:endParaRPr lang="en-US" sz="900" dirty="0"/>
           </a:p>
         </p:txBody>
@@ -18399,7 +17839,7 @@
       </p:sp>
       <p:sp>
         <p:nvSpPr>
-          <p:cNvPr id="4" name="Shape 2"/>
+          <p:cNvPr id="5" name="Text 3"/>
           <p:cNvSpPr/>
           <p:nvPr/>
         </p:nvSpPr>
@@ -18408,40 +17848,6 @@
             <a:off x="8945575" y="457200"/>
             <a:ext cx="2697480" cy="457200"/>
           </a:xfrm>
-          <a:prstGeom prst="roundRect">
-            <a:avLst>
-              <a:gd name="adj" fmla="val 50000"/>
-            </a:avLst>
-          </a:prstGeom>
-          <a:solidFill>
-            <a:srgbClr val="1B2540"/>
-          </a:solidFill>
-          <a:ln w="12700">
-            <a:solidFill>
-              <a:srgbClr val="2A3550"/>
-            </a:solidFill>
-            <a:prstDash val="solid"/>
-          </a:ln>
-        </p:spPr>
-        <p:txBody>
-          <a:bodyPr/>
-          <a:lstStyle/>
-          <a:p>
-            <a:endParaRPr lang="en-US"/>
-          </a:p>
-        </p:txBody>
-      </p:sp>
-      <p:sp>
-        <p:nvSpPr>
-          <p:cNvPr id="5" name="Text 3"/>
-          <p:cNvSpPr/>
-          <p:nvPr/>
-        </p:nvSpPr>
-        <p:spPr>
-          <a:xfrm>
-            <a:off x="8945575" y="457200"/>
-            <a:ext cx="2697480" cy="457200"/>
-          </a:xfrm>
           <a:prstGeom prst="rect">
             <a:avLst/>
           </a:prstGeom>
@@ -18455,28 +17861,6 @@
             <a:pPr marL="0" indent="0" algn="ctr">
               <a:buNone/>
             </a:pPr>
-            <a:r>
-              <a:rPr lang="en-US" sz="900" b="1" kern="0" spc="100" dirty="0">
-                <a:solidFill>
-                  <a:srgbClr val="8A98B5"/>
-                </a:solidFill>
-                <a:latin typeface="Calibri" pitchFamily="34" charset="0"/>
-                <a:ea typeface="Calibri" pitchFamily="34" charset="-122"/>
-                <a:cs typeface="Calibri" pitchFamily="34" charset="-120"/>
-              </a:rPr>
-              <a:t>PRESENTER   </a:t>
-            </a:r>
-            <a:r>
-              <a:rPr lang="en-US" sz="1100" b="1" dirty="0">
-                <a:solidFill>
-                  <a:srgbClr val="FFFFFF"/>
-                </a:solidFill>
-                <a:latin typeface="Calibri" pitchFamily="34" charset="0"/>
-                <a:ea typeface="Calibri" pitchFamily="34" charset="-122"/>
-                <a:cs typeface="Calibri" pitchFamily="34" charset="-120"/>
-              </a:rPr>
-              <a:t>Yash Petkar</a:t>
-            </a:r>
             <a:endParaRPr lang="en-US" sz="900" dirty="0"/>
           </a:p>
         </p:txBody>
@@ -19558,7 +18942,7 @@
       </p:sp>
       <p:sp>
         <p:nvSpPr>
-          <p:cNvPr id="4" name="Shape 2"/>
+          <p:cNvPr id="5" name="Text 3"/>
           <p:cNvSpPr/>
           <p:nvPr/>
         </p:nvSpPr>
@@ -19567,40 +18951,6 @@
             <a:off x="8945575" y="457200"/>
             <a:ext cx="2697480" cy="457200"/>
           </a:xfrm>
-          <a:prstGeom prst="roundRect">
-            <a:avLst>
-              <a:gd name="adj" fmla="val 50000"/>
-            </a:avLst>
-          </a:prstGeom>
-          <a:solidFill>
-            <a:srgbClr val="1B2540"/>
-          </a:solidFill>
-          <a:ln w="12700">
-            <a:solidFill>
-              <a:srgbClr val="2A3550"/>
-            </a:solidFill>
-            <a:prstDash val="solid"/>
-          </a:ln>
-        </p:spPr>
-        <p:txBody>
-          <a:bodyPr/>
-          <a:lstStyle/>
-          <a:p>
-            <a:endParaRPr lang="en-US"/>
-          </a:p>
-        </p:txBody>
-      </p:sp>
-      <p:sp>
-        <p:nvSpPr>
-          <p:cNvPr id="5" name="Text 3"/>
-          <p:cNvSpPr/>
-          <p:nvPr/>
-        </p:nvSpPr>
-        <p:spPr>
-          <a:xfrm>
-            <a:off x="8945575" y="457200"/>
-            <a:ext cx="2697480" cy="457200"/>
-          </a:xfrm>
           <a:prstGeom prst="rect">
             <a:avLst/>
           </a:prstGeom>
@@ -19614,28 +18964,6 @@
             <a:pPr marL="0" indent="0" algn="ctr">
               <a:buNone/>
             </a:pPr>
-            <a:r>
-              <a:rPr lang="en-US" sz="900" b="1" kern="0" spc="100" dirty="0">
-                <a:solidFill>
-                  <a:srgbClr val="8A98B5"/>
-                </a:solidFill>
-                <a:latin typeface="Calibri" pitchFamily="34" charset="0"/>
-                <a:ea typeface="Calibri" pitchFamily="34" charset="-122"/>
-                <a:cs typeface="Calibri" pitchFamily="34" charset="-120"/>
-              </a:rPr>
-              <a:t>PRESENTER   </a:t>
-            </a:r>
-            <a:r>
-              <a:rPr lang="en-US" sz="1100" b="1" dirty="0">
-                <a:solidFill>
-                  <a:srgbClr val="FFFFFF"/>
-                </a:solidFill>
-                <a:latin typeface="Calibri" pitchFamily="34" charset="0"/>
-                <a:ea typeface="Calibri" pitchFamily="34" charset="-122"/>
-                <a:cs typeface="Calibri" pitchFamily="34" charset="-120"/>
-              </a:rPr>
-              <a:t>Krish Kumar</a:t>
-            </a:r>
             <a:endParaRPr lang="en-US" sz="900" dirty="0"/>
           </a:p>
         </p:txBody>
@@ -21651,7 +20979,7 @@
       </p:sp>
       <p:sp>
         <p:nvSpPr>
-          <p:cNvPr id="4" name="Shape 2"/>
+          <p:cNvPr id="5" name="Text 3"/>
           <p:cNvSpPr/>
           <p:nvPr/>
         </p:nvSpPr>
@@ -21660,40 +20988,6 @@
             <a:off x="8945575" y="457200"/>
             <a:ext cx="2697480" cy="457200"/>
           </a:xfrm>
-          <a:prstGeom prst="roundRect">
-            <a:avLst>
-              <a:gd name="adj" fmla="val 50000"/>
-            </a:avLst>
-          </a:prstGeom>
-          <a:solidFill>
-            <a:srgbClr val="1B2540"/>
-          </a:solidFill>
-          <a:ln w="12700">
-            <a:solidFill>
-              <a:srgbClr val="2A3550"/>
-            </a:solidFill>
-            <a:prstDash val="solid"/>
-          </a:ln>
-        </p:spPr>
-        <p:txBody>
-          <a:bodyPr/>
-          <a:lstStyle/>
-          <a:p>
-            <a:endParaRPr lang="en-US"/>
-          </a:p>
-        </p:txBody>
-      </p:sp>
-      <p:sp>
-        <p:nvSpPr>
-          <p:cNvPr id="5" name="Text 3"/>
-          <p:cNvSpPr/>
-          <p:nvPr/>
-        </p:nvSpPr>
-        <p:spPr>
-          <a:xfrm>
-            <a:off x="8945575" y="457200"/>
-            <a:ext cx="2697480" cy="457200"/>
-          </a:xfrm>
           <a:prstGeom prst="rect">
             <a:avLst/>
           </a:prstGeom>
@@ -21707,28 +21001,6 @@
             <a:pPr marL="0" indent="0" algn="ctr">
               <a:buNone/>
             </a:pPr>
-            <a:r>
-              <a:rPr lang="en-US" sz="900" b="1" kern="0" spc="100" dirty="0">
-                <a:solidFill>
-                  <a:srgbClr val="8A98B5"/>
-                </a:solidFill>
-                <a:latin typeface="Calibri" pitchFamily="34" charset="0"/>
-                <a:ea typeface="Calibri" pitchFamily="34" charset="-122"/>
-                <a:cs typeface="Calibri" pitchFamily="34" charset="-120"/>
-              </a:rPr>
-              <a:t>PRESENTER   </a:t>
-            </a:r>
-            <a:r>
-              <a:rPr lang="en-US" sz="1100" b="1" dirty="0">
-                <a:solidFill>
-                  <a:srgbClr val="FFFFFF"/>
-                </a:solidFill>
-                <a:latin typeface="Calibri" pitchFamily="34" charset="0"/>
-                <a:ea typeface="Calibri" pitchFamily="34" charset="-122"/>
-                <a:cs typeface="Calibri" pitchFamily="34" charset="-120"/>
-              </a:rPr>
-              <a:t>Atharva Soundankar</a:t>
-            </a:r>
             <a:endParaRPr lang="en-US" sz="900" dirty="0"/>
           </a:p>
         </p:txBody>
@@ -22609,7 +21881,7 @@
         </p:nvSpPr>
         <p:spPr>
           <a:xfrm>
-            <a:off x="548640" y="658368"/>
+            <a:off x="312268" y="708660"/>
             <a:ext cx="8869680" cy="868680"/>
           </a:xfrm>
           <a:prstGeom prst="rect">
@@ -22642,7 +21914,7 @@
       </p:sp>
       <p:sp>
         <p:nvSpPr>
-          <p:cNvPr id="4" name="Shape 2"/>
+          <p:cNvPr id="5" name="Text 3"/>
           <p:cNvSpPr/>
           <p:nvPr/>
         </p:nvSpPr>
@@ -22651,40 +21923,6 @@
             <a:off x="8945575" y="457200"/>
             <a:ext cx="2697480" cy="457200"/>
           </a:xfrm>
-          <a:prstGeom prst="roundRect">
-            <a:avLst>
-              <a:gd name="adj" fmla="val 50000"/>
-            </a:avLst>
-          </a:prstGeom>
-          <a:solidFill>
-            <a:srgbClr val="1B2540"/>
-          </a:solidFill>
-          <a:ln w="12700">
-            <a:solidFill>
-              <a:srgbClr val="2A3550"/>
-            </a:solidFill>
-            <a:prstDash val="solid"/>
-          </a:ln>
-        </p:spPr>
-        <p:txBody>
-          <a:bodyPr/>
-          <a:lstStyle/>
-          <a:p>
-            <a:endParaRPr lang="en-US"/>
-          </a:p>
-        </p:txBody>
-      </p:sp>
-      <p:sp>
-        <p:nvSpPr>
-          <p:cNvPr id="5" name="Text 3"/>
-          <p:cNvSpPr/>
-          <p:nvPr/>
-        </p:nvSpPr>
-        <p:spPr>
-          <a:xfrm>
-            <a:off x="8945575" y="457200"/>
-            <a:ext cx="2697480" cy="457200"/>
-          </a:xfrm>
           <a:prstGeom prst="rect">
             <a:avLst/>
           </a:prstGeom>
@@ -22698,28 +21936,6 @@
             <a:pPr marL="0" indent="0" algn="ctr">
               <a:buNone/>
             </a:pPr>
-            <a:r>
-              <a:rPr lang="en-US" sz="900" b="1" kern="0" spc="100" dirty="0">
-                <a:solidFill>
-                  <a:srgbClr val="8A98B5"/>
-                </a:solidFill>
-                <a:latin typeface="Calibri" pitchFamily="34" charset="0"/>
-                <a:ea typeface="Calibri" pitchFamily="34" charset="-122"/>
-                <a:cs typeface="Calibri" pitchFamily="34" charset="-120"/>
-              </a:rPr>
-              <a:t>PRESENTER   </a:t>
-            </a:r>
-            <a:r>
-              <a:rPr lang="en-US" sz="1100" b="1" dirty="0">
-                <a:solidFill>
-                  <a:srgbClr val="FFFFFF"/>
-                </a:solidFill>
-                <a:latin typeface="Calibri" pitchFamily="34" charset="0"/>
-                <a:ea typeface="Calibri" pitchFamily="34" charset="-122"/>
-                <a:cs typeface="Calibri" pitchFamily="34" charset="-120"/>
-              </a:rPr>
-              <a:t>Krishna Mathur</a:t>
-            </a:r>
             <a:endParaRPr lang="en-US" sz="900" dirty="0"/>
           </a:p>
         </p:txBody>

</xml_diff>